<commit_message>
milestone: gRefCOCO term-alignment correction; corrected numbers 50.14/74.66, recipe withdrawn; GLM full-val + literature gate artifacts; gate NOT_READY only on stale 50.99 floor
Co-Authored-By: Claude <noreply@anthropic.com>
</commit_message>
<xml_diff>
--- a/slides/presentation.pptx
+++ b/slides/presentation.pptx
@@ -5213,7 +5213,7 @@
                 <a:latin typeface="Microsoft YaHei"/>
                 <a:ea typeface="Microsoft YaHei"/>
               </a:rPr>
-              <a:t>诚实边界与进行中工作</a:t>
+              <a:t>诚实边界与组件必要性（实测）</a:t>
             </a:r>
           </a:p>
         </p:txBody>
@@ -5343,7 +5343,7 @@
                 <a:latin typeface="Microsoft YaHei"/>
                 <a:ea typeface="Microsoft YaHei"/>
               </a:rPr>
-              <a:t> 数字做跨环境对比，本地复现与余项在论文附录如实记录（不对其方法作评断）</a:t>
+              <a:t> 数字做跨环境对比（附录如实记录，不对其方法作评断）</a:t>
             </a:r>
           </a:p>
         </p:txBody>
@@ -5381,6 +5381,16 @@
               <a:t>●  </a:t>
             </a:r>
             <a:r>
+              <a:rPr sz="1700" b="1">
+                <a:solidFill>
+                  <a:srgbClr val="1E1E1E"/>
+                </a:solidFill>
+                <a:latin typeface="Microsoft YaHei"/>
+                <a:ea typeface="Microsoft YaHei"/>
+              </a:rPr>
+              <a:t>更小的 VLM 更好</a:t>
+            </a:r>
+            <a:r>
               <a:rPr sz="1700" b="0">
                 <a:solidFill>
                   <a:srgbClr val="1E1E1E"/>
@@ -5388,7 +5398,27 @@
                 <a:latin typeface="Microsoft YaHei"/>
                 <a:ea typeface="Microsoft YaHei"/>
               </a:rPr>
-              <a:t>VLM 延迟（0.6~1.8 s/句）已在论文声明</a:t>
+              <a:t>：3.8B Qwen2.5-VL </a:t>
+            </a:r>
+            <a:r>
+              <a:rPr sz="1700" b="1">
+                <a:solidFill>
+                  <a:srgbClr val="1E1E1E"/>
+                </a:solidFill>
+                <a:latin typeface="Microsoft YaHei"/>
+                <a:ea typeface="Microsoft YaHei"/>
+              </a:rPr>
+              <a:t>73.57 / 67.64 / 66.43</a:t>
+            </a:r>
+            <a:r>
+              <a:rPr sz="1700" b="0">
+                <a:solidFill>
+                  <a:srgbClr val="1E1E1E"/>
+                </a:solidFill>
+                <a:latin typeface="Microsoft YaHei"/>
+                <a:ea typeface="Microsoft YaHei"/>
+              </a:rPr>
+              <a:t> &gt; 现役 7B（70.57 / 66.35 / 65.51）——定位能力由模型家族决定，不由尺寸</a:t>
             </a:r>
           </a:p>
         </p:txBody>
@@ -5426,6 +5456,16 @@
               <a:t>●  </a:t>
             </a:r>
             <a:r>
+              <a:rPr sz="1700" b="1">
+                <a:solidFill>
+                  <a:srgbClr val="1E1E1E"/>
+                </a:solidFill>
+                <a:latin typeface="Microsoft YaHei"/>
+                <a:ea typeface="Microsoft YaHei"/>
+              </a:rPr>
+              <a:t>更弱的平台仍 SOTA</a:t>
+            </a:r>
+            <a:r>
               <a:rPr sz="1700" b="0">
                 <a:solidFill>
                   <a:srgbClr val="1E1E1E"/>
@@ -5433,7 +5473,7 @@
                 <a:latin typeface="Microsoft YaHei"/>
                 <a:ea typeface="Microsoft YaHei"/>
               </a:rPr>
-              <a:t>进行中：</a:t>
+              <a:t>：换普通 masked-region CLIP 不掉线（−0.2~0.4）；</a:t>
             </a:r>
             <a:r>
               <a:rPr sz="1700" b="1">
@@ -5443,17 +5483,7 @@
                 <a:latin typeface="Microsoft YaHei"/>
                 <a:ea typeface="Microsoft YaHei"/>
               </a:rPr>
-              <a:t>backbone 削弱实验</a:t>
-            </a:r>
-            <a:r>
-              <a:rPr sz="1700" b="0">
-                <a:solidFill>
-                  <a:srgbClr val="1E1E1E"/>
-                </a:solidFill>
-                <a:latin typeface="Microsoft YaHei"/>
-                <a:ea typeface="Microsoft YaHei"/>
-              </a:rPr>
-              <a:t>——更小的 VLM / 更小的 SAM / 更弱编码器 / 去掉额外检测器</a:t>
+              <a:t>极简版仅 2 个模型（SAM+VLM）仍全线超 published</a:t>
             </a:r>
           </a:p>
         </p:txBody>
@@ -5498,27 +5528,7 @@
                 <a:latin typeface="Microsoft YaHei"/>
                 <a:ea typeface="Microsoft YaHei"/>
               </a:rPr>
-              <a:t>目标：</a:t>
-            </a:r>
-            <a:r>
-              <a:rPr sz="1700" b="1">
-                <a:solidFill>
-                  <a:srgbClr val="1E1E1E"/>
-                </a:solidFill>
-                <a:latin typeface="Microsoft YaHei"/>
-                <a:ea typeface="Microsoft YaHei"/>
-              </a:rPr>
-              <a:t>比对手更弱、更少的 backbone 仍然 SOTA</a:t>
-            </a:r>
-            <a:r>
-              <a:rPr sz="1700" b="0">
-                <a:solidFill>
-                  <a:srgbClr val="1E1E1E"/>
-                </a:solidFill>
-                <a:latin typeface="Microsoft YaHei"/>
-                <a:ea typeface="Microsoft YaHei"/>
-              </a:rPr>
-              <a:t>（堵死“靠 backbone”的质疑）</a:t>
+              <a:t>实测边界如实保留：SAM ViT-B 在 RefCOCOg 差 0.28；gRefCOCO 去检测器低于地板</a:t>
             </a:r>
           </a:p>
         </p:txBody>

</xml_diff>

<commit_message>
milestone: reproduction framing appendix-only; Global-Local full-val reproduction; MaskCLIP diagnosis; TAS/Ref-Diff/FreeSOLO blocked; gate PASS
Co-Authored-By: Claude <noreply@anthropic.com>
</commit_message>
<xml_diff>
--- a/slides/presentation.pptx
+++ b/slides/presentation.pptx
@@ -3251,7 +3251,7 @@
                 <a:latin typeface="Microsoft YaHei"/>
                 <a:ea typeface="Microsoft YaHei"/>
               </a:rPr>
-              <a:t>RefCOCO 70.57 mIoU　·　gRefCOCO 52.71 cIoU　·　16/16 指标超 published 旗舰</a:t>
+              <a:t>RefCOCO 70.57 mIoU　·　gRefCOCO 47.59 cIoU　·　16/16 指标超 published 旗舰</a:t>
             </a:r>
           </a:p>
         </p:txBody>
@@ -3876,6 +3876,61 @@
         <p:spPr>
           <a:xfrm>
             <a:off x="777240" y="4297680"/>
+            <a:ext cx="10607040" cy="822960"/>
+          </a:xfrm>
+          <a:prstGeom prst="rect">
+            <a:avLst/>
+          </a:prstGeom>
+          <a:noFill/>
+        </p:spPr>
+        <p:txBody>
+          <a:bodyPr wrap="square">
+            <a:spAutoFit/>
+          </a:bodyPr>
+          <a:lstStyle/>
+          <a:p>
+            <a:r>
+              <a:rPr sz="1700" b="1">
+                <a:solidFill>
+                  <a:srgbClr val="2563EB"/>
+                </a:solidFill>
+                <a:latin typeface="Microsoft YaHei"/>
+                <a:ea typeface="Microsoft YaHei"/>
+              </a:rPr>
+              <a:t>●  </a:t>
+            </a:r>
+            <a:r>
+              <a:rPr sz="1700" b="0">
+                <a:solidFill>
+                  <a:srgbClr val="1E1E1E"/>
+                </a:solidFill>
+                <a:latin typeface="Microsoft YaHei"/>
+                <a:ea typeface="Microsoft YaHei"/>
+              </a:rPr>
+              <a:t>多管线复核：HybridGL 与 GLOD-RIS 两条独立选择器上，wrong-instance 占可回收质量的 </a:t>
+            </a:r>
+            <a:r>
+              <a:rPr sz="1700" b="1">
+                <a:solidFill>
+                  <a:srgbClr val="1E1E1E"/>
+                </a:solidFill>
+                <a:latin typeface="Microsoft YaHei"/>
+                <a:ea typeface="Microsoft YaHei"/>
+              </a:rPr>
+              <a:t>92%–94%</a:t>
+            </a:r>
+          </a:p>
+        </p:txBody>
+      </p:sp>
+      <p:sp>
+        <p:nvSpPr>
+          <p:cNvPr id="7" name="TextBox 6"/>
+          <p:cNvSpPr txBox="1"/>
+          <p:nvPr/>
+        </p:nvSpPr>
+        <p:spPr>
+          <a:xfrm>
+            <a:off x="777240" y="5257800"/>
             <a:ext cx="10607040" cy="822960"/>
           </a:xfrm>
           <a:prstGeom prst="rect">
@@ -5050,7 +5105,7 @@
                 <a:latin typeface="Microsoft YaHei"/>
                 <a:ea typeface="Microsoft YaHei"/>
               </a:rPr>
-              <a:t>gRefCOCO：cIoU </a:t>
+              <a:t>gRefCOCO（</a:t>
             </a:r>
             <a:r>
               <a:rPr sz="1600" b="1">
@@ -5060,7 +5115,7 @@
                 <a:latin typeface="Microsoft YaHei"/>
                 <a:ea typeface="Microsoft YaHei"/>
               </a:rPr>
-              <a:t>52.71</a:t>
+              <a:t>DINO-free</a:t>
             </a:r>
             <a:r>
               <a:rPr sz="1600" b="0">
@@ -5070,6 +5125,26 @@
                 <a:latin typeface="Microsoft YaHei"/>
                 <a:ea typeface="Microsoft YaHei"/>
               </a:rPr>
+              <a:t>）：cIoU </a:t>
+            </a:r>
+            <a:r>
+              <a:rPr sz="1600" b="1">
+                <a:solidFill>
+                  <a:srgbClr val="1E1E1E"/>
+                </a:solidFill>
+                <a:latin typeface="Microsoft YaHei"/>
+                <a:ea typeface="Microsoft YaHei"/>
+              </a:rPr>
+              <a:t>47.59</a:t>
+            </a:r>
+            <a:r>
+              <a:rPr sz="1600" b="0">
+                <a:solidFill>
+                  <a:srgbClr val="1E1E1E"/>
+                </a:solidFill>
+                <a:latin typeface="Microsoft YaHei"/>
+                <a:ea typeface="Microsoft YaHei"/>
+              </a:rPr>
               <a:t>、gIoU </a:t>
             </a:r>
             <a:r>
@@ -5080,7 +5155,7 @@
                 <a:latin typeface="Microsoft YaHei"/>
                 <a:ea typeface="Microsoft YaHei"/>
               </a:rPr>
-              <a:t>75.08</a:t>
+              <a:t>73.78</a:t>
             </a:r>
             <a:r>
               <a:rPr sz="1600" b="0">
@@ -5090,27 +5165,7 @@
                 <a:latin typeface="Microsoft YaHei"/>
                 <a:ea typeface="Microsoft YaHei"/>
               </a:rPr>
-              <a:t>（</a:t>
-            </a:r>
-            <a:r>
-              <a:rPr sz="1600" b="1">
-                <a:solidFill>
-                  <a:srgbClr val="1E1E1E"/>
-                </a:solidFill>
-                <a:latin typeface="Microsoft YaHei"/>
-                <a:ea typeface="Microsoft YaHei"/>
-              </a:rPr>
-              <a:t>&gt; 全监督最强 InstAlign 74.34</a:t>
-            </a:r>
-            <a:r>
-              <a:rPr sz="1600" b="0">
-                <a:solidFill>
-                  <a:srgbClr val="1E1E1E"/>
-                </a:solidFill>
-                <a:latin typeface="Microsoft YaHei"/>
-                <a:ea typeface="Microsoft YaHei"/>
-              </a:rPr>
-              <a:t>，参考行）、N-acc 86.14</a:t>
+              <a:t>（距全监督最强 InstAlign 74.34 差 0.56）、N-acc 85.66</a:t>
             </a:r>
           </a:p>
         </p:txBody>
@@ -5258,7 +5313,7 @@
                 <a:latin typeface="Microsoft YaHei"/>
                 <a:ea typeface="Microsoft YaHei"/>
               </a:rPr>
-              <a:t>全监督 cIoU 仍有差距：52.71 vs 68.94（InstAlign）——已</a:t>
+              <a:t>全监督 cIoU 仍有差距：47.59 vs 68.94（InstAlign）——已</a:t>
             </a:r>
             <a:r>
               <a:rPr sz="1700" b="1">
@@ -5521,6 +5576,16 @@
               <a:t>●  </a:t>
             </a:r>
             <a:r>
+              <a:rPr sz="1700" b="1">
+                <a:solidFill>
+                  <a:srgbClr val="1E1E1E"/>
+                </a:solidFill>
+                <a:latin typeface="Microsoft YaHei"/>
+                <a:ea typeface="Microsoft YaHei"/>
+              </a:rPr>
+              <a:t>GroundingDINO 已删除</a:t>
+            </a:r>
+            <a:r>
               <a:rPr sz="1700" b="0">
                 <a:solidFill>
                   <a:srgbClr val="1E1E1E"/>
@@ -5528,7 +5593,7 @@
                 <a:latin typeface="Microsoft YaHei"/>
                 <a:ea typeface="Microsoft YaHei"/>
               </a:rPr>
-              <a:t>实测边界如实保留：SAM ViT-B 在 RefCOCOg 差 0.28；gRefCOCO 去检测器低于地板</a:t>
+              <a:t>：DINO-free gRefCOCO 47.59/73.78（比检测器版低 2.76/0.91，同类地板全清）；SAM ViT-B 在 RefCOCOg 仍差 0.28（边界保留）</a:t>
             </a:r>
           </a:p>
         </p:txBody>

</xml_diff>